<commit_message>
Plantilla base con estilos de diapositiva vacíos
Un solo archivo con 24 estilos genéricos y la biblioteca de íconos, para que
el docente arme su contenido. Ajuste de la cinta de sección en las otras tres.

Co-Authored-By: Claude Fable 5.1 <noreply@anthropic.com>
Claude-Session: https://claude.ai/code/session_01Ja1vbRoiAwxTq3mLFGrVau
</commit_message>
<xml_diff>
--- a/plantillas-taller/Plantilla taller · Consultorio.pptx
+++ b/plantillas-taller/Plantilla taller · Consultorio.pptx
@@ -118,7 +118,7 @@
   <p:extLst>
     <p:ext uri="{521415D9-36F7-43E2-AB2F-B90AF26B5E84}">
       <p14:sectionLst xmlns:p14="http://schemas.microsoft.com/office/powerpoint/2010/main">
-        <p14:section name="Consultorio" id="{df4e1b8d-539c-4463-a702-920efe5f12f9}">
+        <p14:section name="Consultorio" id="{ba8fb449-e0da-e47e-156e-d06cfcb7ab7d}">
           <p14:sldIdLst>
             <p14:sldId id="256"/>
             <p14:sldId id="257"/>
@@ -2925,8 +2925,8 @@
         </p:nvSpPr>
         <p:spPr>
           <a:xfrm>
-            <a:off x="1143000" y="4434840"/>
-            <a:ext cx="4069080" cy="502920"/>
+            <a:off x="1145286" y="4434840"/>
+            <a:ext cx="4066794" cy="502920"/>
           </a:xfrm>
           <a:prstGeom prst="rect">
             <a:avLst/>
@@ -5609,8 +5609,8 @@
         </p:nvSpPr>
         <p:spPr>
           <a:xfrm>
-            <a:off x="7223760" y="1600200"/>
-            <a:ext cx="3977640" cy="457200"/>
+            <a:off x="7200900" y="1600200"/>
+            <a:ext cx="4000500" cy="457200"/>
           </a:xfrm>
           <a:prstGeom prst="rect">
             <a:avLst/>
@@ -11034,8 +11034,8 @@
         </p:nvSpPr>
         <p:spPr>
           <a:xfrm>
-            <a:off x="1143000" y="3840480"/>
-            <a:ext cx="4983480" cy="457200"/>
+            <a:off x="1120140" y="3840480"/>
+            <a:ext cx="5006340" cy="457200"/>
           </a:xfrm>
           <a:prstGeom prst="rect">
             <a:avLst/>

</xml_diff>